<commit_message>
Draw the six Chapter 3 charts, with five chart forms added to chartkit
Each chart draws a construction the book describes and none of its forty
figures shows: the four gap types measured in pesos on one pair of bars,
a line chart over the highs and lows it discards, point and figure
columns built box by box with a 3 box reversal, where constant volume
bars close in a session, the book's 10 to 20 and 90 to 100 on linear,
square root and ratio axes, and back adjusting through discount rolls
until early history goes below zero.

The new forms are additions only. Both editions of Chapters 1 and 2
rebuild byte for byte, and both Chapter 3 decks embed exactly the six
images in build/generated/charts-03.

Co-Authored-By: Claude Opus 5 (1M context) <noreply@anthropic.com>
</commit_message>
<xml_diff>
--- a/chapter-03/FIN1209-Chapter-03-Student-Edition.pptx
+++ b/chapter-03/FIN1209-Chapter-03-Student-Edition.pptx
@@ -20016,8 +20016,8 @@
         </p:nvSpPr>
         <p:spPr>
           <a:xfrm>
-            <a:off x="2346807" y="1810512"/>
-            <a:ext cx="7498079" cy="3749039"/>
+            <a:off x="778611" y="1810512"/>
+            <a:ext cx="10634472" cy="3749039"/>
           </a:xfrm>
           <a:prstGeom prst="rect">
             <a:avLst/>
@@ -20040,128 +20040,33 @@
           </a:p>
         </p:txBody>
       </p:sp>
-      <p:sp>
-        <p:nvSpPr>
-          <p:cNvPr id="8" name="Rectangle 7"/>
-          <p:cNvSpPr/>
-          <p:nvPr/>
-        </p:nvSpPr>
-        <p:spPr>
-          <a:xfrm>
-            <a:off x="2346807" y="1810512"/>
-            <a:ext cx="7498079" cy="50800"/>
-          </a:xfrm>
-          <a:prstGeom prst="rect">
-            <a:avLst/>
-          </a:prstGeom>
-          <a:solidFill>
-            <a:srgbClr val="F2A900"/>
-          </a:solidFill>
-          <a:ln>
-            <a:noFill/>
-          </a:ln>
-          <a:effectLst/>
-        </p:spPr>
-        <p:txBody>
-          <a:bodyPr rtlCol="0" anchor="ctr"/>
-          <a:lstStyle/>
-          <a:p>
-            <a:pPr algn="ctr"/>
-          </a:p>
-        </p:txBody>
-      </p:sp>
+      <p:pic>
+        <p:nvPicPr>
+          <p:cNvPr id="8" name="Picture 7" descr="chart-f.png"/>
+          <p:cNvPicPr>
+            <a:picLocks noChangeAspect="1"/>
+          </p:cNvPicPr>
+          <p:nvPr/>
+        </p:nvPicPr>
+        <p:blipFill>
+          <a:blip r:embed="rId2"/>
+          <a:stretch>
+            <a:fillRect/>
+          </a:stretch>
+        </p:blipFill>
+        <p:spPr>
+          <a:xfrm>
+            <a:off x="897483" y="1929384"/>
+            <a:ext cx="10396728" cy="3511296"/>
+          </a:xfrm>
+          <a:prstGeom prst="rect">
+            <a:avLst/>
+          </a:prstGeom>
+        </p:spPr>
+      </p:pic>
       <p:sp>
         <p:nvSpPr>
           <p:cNvPr id="9" name="TextBox 8"/>
-          <p:cNvSpPr txBox="1"/>
-          <p:nvPr/>
-        </p:nvSpPr>
-        <p:spPr>
-          <a:xfrm>
-            <a:off x="2895447" y="2450591"/>
-            <a:ext cx="6400799" cy="2651759"/>
-          </a:xfrm>
-          <a:prstGeom prst="rect">
-            <a:avLst/>
-          </a:prstGeom>
-          <a:noFill/>
-        </p:spPr>
-        <p:txBody>
-          <a:bodyPr wrap="square" anchor="t" lIns="0" rIns="0" tIns="0" bIns="0">
-            <a:spAutoFit/>
-          </a:bodyPr>
-          <a:lstStyle/>
-          <a:p>
-            <a:pPr algn="l">
-              <a:lnSpc>
-                <a:spcPct val="100000"/>
-              </a:lnSpc>
-              <a:spcBef>
-                <a:spcPts val="0"/>
-              </a:spcBef>
-              <a:spcAft>
-                <a:spcPts val="1400"/>
-              </a:spcAft>
-            </a:pPr>
-            <a:r>
-              <a:rPr sz="1500" b="1" i="0">
-                <a:solidFill>
-                  <a:srgbClr val="818181"/>
-                </a:solidFill>
-                <a:latin typeface="Arial"/>
-              </a:rPr>
-              <a:t>CHART F</a:t>
-            </a:r>
-          </a:p>
-          <a:p>
-            <a:pPr algn="l">
-              <a:lnSpc>
-                <a:spcPct val="120000"/>
-              </a:lnSpc>
-              <a:spcBef>
-                <a:spcPts val="0"/>
-              </a:spcBef>
-              <a:spcAft>
-                <a:spcPts val="1800"/>
-              </a:spcAft>
-            </a:pPr>
-            <a:r>
-              <a:rPr sz="2200" b="0" i="0">
-                <a:solidFill>
-                  <a:srgbClr val="1A1A1A"/>
-                </a:solidFill>
-                <a:latin typeface="Palatino"/>
-              </a:rPr>
-              <a:t>Contracts joined end to end, each new one at a discount to the last, and the same string back adjusted into one continuous line whose earliest prices fall below zero.</a:t>
-            </a:r>
-          </a:p>
-          <a:p>
-            <a:pPr algn="l">
-              <a:lnSpc>
-                <a:spcPct val="115000"/>
-              </a:lnSpc>
-              <a:spcBef>
-                <a:spcPts val="0"/>
-              </a:spcBef>
-              <a:spcAft>
-                <a:spcPts val="0"/>
-              </a:spcAft>
-            </a:pPr>
-            <a:r>
-              <a:rPr sz="1400" b="0" i="1">
-                <a:solidFill>
-                  <a:srgbClr val="818181"/>
-                </a:solidFill>
-                <a:latin typeface="Arial"/>
-              </a:rPr>
-              <a:t>This chart is generated by build/chartkit.py and was not drawn for this build. Rerun the build to place it.</a:t>
-            </a:r>
-          </a:p>
-        </p:txBody>
-      </p:sp>
-      <p:sp>
-        <p:nvSpPr>
-          <p:cNvPr id="10" name="TextBox 9"/>
           <p:cNvSpPr txBox="1"/>
           <p:nvPr/>
         </p:nvSpPr>
@@ -33280,8 +33185,8 @@
         </p:nvSpPr>
         <p:spPr>
           <a:xfrm>
-            <a:off x="2346807" y="1810512"/>
-            <a:ext cx="7498079" cy="3749039"/>
+            <a:off x="778611" y="1810512"/>
+            <a:ext cx="10634472" cy="3749039"/>
           </a:xfrm>
           <a:prstGeom prst="rect">
             <a:avLst/>
@@ -33304,128 +33209,33 @@
           </a:p>
         </p:txBody>
       </p:sp>
-      <p:sp>
-        <p:nvSpPr>
-          <p:cNvPr id="8" name="Rectangle 7"/>
-          <p:cNvSpPr/>
-          <p:nvPr/>
-        </p:nvSpPr>
-        <p:spPr>
-          <a:xfrm>
-            <a:off x="2346807" y="1810512"/>
-            <a:ext cx="7498079" cy="50800"/>
-          </a:xfrm>
-          <a:prstGeom prst="rect">
-            <a:avLst/>
-          </a:prstGeom>
-          <a:solidFill>
-            <a:srgbClr val="F2A900"/>
-          </a:solidFill>
-          <a:ln>
-            <a:noFill/>
-          </a:ln>
-          <a:effectLst/>
-        </p:spPr>
-        <p:txBody>
-          <a:bodyPr rtlCol="0" anchor="ctr"/>
-          <a:lstStyle/>
-          <a:p>
-            <a:pPr algn="ctr"/>
-          </a:p>
-        </p:txBody>
-      </p:sp>
+      <p:pic>
+        <p:nvPicPr>
+          <p:cNvPr id="8" name="Picture 7" descr="chart-a.png"/>
+          <p:cNvPicPr>
+            <a:picLocks noChangeAspect="1"/>
+          </p:cNvPicPr>
+          <p:nvPr/>
+        </p:nvPicPr>
+        <p:blipFill>
+          <a:blip r:embed="rId2"/>
+          <a:stretch>
+            <a:fillRect/>
+          </a:stretch>
+        </p:blipFill>
+        <p:spPr>
+          <a:xfrm>
+            <a:off x="897483" y="1929384"/>
+            <a:ext cx="10396728" cy="3511296"/>
+          </a:xfrm>
+          <a:prstGeom prst="rect">
+            <a:avLst/>
+          </a:prstGeom>
+        </p:spPr>
+      </p:pic>
       <p:sp>
         <p:nvSpPr>
           <p:cNvPr id="9" name="TextBox 8"/>
-          <p:cNvSpPr txBox="1"/>
-          <p:nvPr/>
-        </p:nvSpPr>
-        <p:spPr>
-          <a:xfrm>
-            <a:off x="2895447" y="2450591"/>
-            <a:ext cx="6400799" cy="2651759"/>
-          </a:xfrm>
-          <a:prstGeom prst="rect">
-            <a:avLst/>
-          </a:prstGeom>
-          <a:noFill/>
-        </p:spPr>
-        <p:txBody>
-          <a:bodyPr wrap="square" anchor="t" lIns="0" rIns="0" tIns="0" bIns="0">
-            <a:spAutoFit/>
-          </a:bodyPr>
-          <a:lstStyle/>
-          <a:p>
-            <a:pPr algn="l">
-              <a:lnSpc>
-                <a:spcPct val="100000"/>
-              </a:lnSpc>
-              <a:spcBef>
-                <a:spcPts val="0"/>
-              </a:spcBef>
-              <a:spcAft>
-                <a:spcPts val="1400"/>
-              </a:spcAft>
-            </a:pPr>
-            <a:r>
-              <a:rPr sz="1500" b="1" i="0">
-                <a:solidFill>
-                  <a:srgbClr val="818181"/>
-                </a:solidFill>
-                <a:latin typeface="Arial"/>
-              </a:rPr>
-              <a:t>CHART A</a:t>
-            </a:r>
-          </a:p>
-          <a:p>
-            <a:pPr algn="l">
-              <a:lnSpc>
-                <a:spcPct val="120000"/>
-              </a:lnSpc>
-              <a:spcBef>
-                <a:spcPts val="0"/>
-              </a:spcBef>
-              <a:spcAft>
-                <a:spcPts val="1800"/>
-              </a:spcAft>
-            </a:pPr>
-            <a:r>
-              <a:rPr sz="2200" b="0" i="0">
-                <a:solidFill>
-                  <a:srgbClr val="1A1A1A"/>
-                </a:solidFill>
-                <a:latin typeface="Palatino"/>
-              </a:rPr>
-              <a:t>Two bars in pesos, the first with a high of 104 and a close of 102, the second opening at 106 with a low of 105.50, and the four gaps measured between them: 4, 2, 1.50 and 3.50.</a:t>
-            </a:r>
-          </a:p>
-          <a:p>
-            <a:pPr algn="l">
-              <a:lnSpc>
-                <a:spcPct val="115000"/>
-              </a:lnSpc>
-              <a:spcBef>
-                <a:spcPts val="0"/>
-              </a:spcBef>
-              <a:spcAft>
-                <a:spcPts val="0"/>
-              </a:spcAft>
-            </a:pPr>
-            <a:r>
-              <a:rPr sz="1400" b="0" i="1">
-                <a:solidFill>
-                  <a:srgbClr val="818181"/>
-                </a:solidFill>
-                <a:latin typeface="Arial"/>
-              </a:rPr>
-              <a:t>This chart is generated by build/chartkit.py and was not drawn for this build. Rerun the build to place it.</a:t>
-            </a:r>
-          </a:p>
-        </p:txBody>
-      </p:sp>
-      <p:sp>
-        <p:nvSpPr>
-          <p:cNvPr id="10" name="TextBox 9"/>
           <p:cNvSpPr txBox="1"/>
           <p:nvPr/>
         </p:nvSpPr>
@@ -38740,8 +38550,8 @@
         </p:nvSpPr>
         <p:spPr>
           <a:xfrm>
-            <a:off x="2346807" y="1810512"/>
-            <a:ext cx="7498079" cy="3749039"/>
+            <a:off x="778611" y="1810512"/>
+            <a:ext cx="10634472" cy="3749039"/>
           </a:xfrm>
           <a:prstGeom prst="rect">
             <a:avLst/>
@@ -38764,128 +38574,33 @@
           </a:p>
         </p:txBody>
       </p:sp>
-      <p:sp>
-        <p:nvSpPr>
-          <p:cNvPr id="8" name="Rectangle 7"/>
-          <p:cNvSpPr/>
-          <p:nvPr/>
-        </p:nvSpPr>
-        <p:spPr>
-          <a:xfrm>
-            <a:off x="2346807" y="1810512"/>
-            <a:ext cx="7498079" cy="50800"/>
-          </a:xfrm>
-          <a:prstGeom prst="rect">
-            <a:avLst/>
-          </a:prstGeom>
-          <a:solidFill>
-            <a:srgbClr val="F2A900"/>
-          </a:solidFill>
-          <a:ln>
-            <a:noFill/>
-          </a:ln>
-          <a:effectLst/>
-        </p:spPr>
-        <p:txBody>
-          <a:bodyPr rtlCol="0" anchor="ctr"/>
-          <a:lstStyle/>
-          <a:p>
-            <a:pPr algn="ctr"/>
-          </a:p>
-        </p:txBody>
-      </p:sp>
+      <p:pic>
+        <p:nvPicPr>
+          <p:cNvPr id="8" name="Picture 7" descr="chart-b.png"/>
+          <p:cNvPicPr>
+            <a:picLocks noChangeAspect="1"/>
+          </p:cNvPicPr>
+          <p:nvPr/>
+        </p:nvPicPr>
+        <p:blipFill>
+          <a:blip r:embed="rId2"/>
+          <a:stretch>
+            <a:fillRect/>
+          </a:stretch>
+        </p:blipFill>
+        <p:spPr>
+          <a:xfrm>
+            <a:off x="897483" y="1929384"/>
+            <a:ext cx="10396728" cy="3511296"/>
+          </a:xfrm>
+          <a:prstGeom prst="rect">
+            <a:avLst/>
+          </a:prstGeom>
+        </p:spPr>
+      </p:pic>
       <p:sp>
         <p:nvSpPr>
           <p:cNvPr id="9" name="TextBox 8"/>
-          <p:cNvSpPr txBox="1"/>
-          <p:nvPr/>
-        </p:nvSpPr>
-        <p:spPr>
-          <a:xfrm>
-            <a:off x="2895447" y="2450591"/>
-            <a:ext cx="6400799" cy="2651759"/>
-          </a:xfrm>
-          <a:prstGeom prst="rect">
-            <a:avLst/>
-          </a:prstGeom>
-          <a:noFill/>
-        </p:spPr>
-        <p:txBody>
-          <a:bodyPr wrap="square" anchor="t" lIns="0" rIns="0" tIns="0" bIns="0">
-            <a:spAutoFit/>
-          </a:bodyPr>
-          <a:lstStyle/>
-          <a:p>
-            <a:pPr algn="l">
-              <a:lnSpc>
-                <a:spcPct val="100000"/>
-              </a:lnSpc>
-              <a:spcBef>
-                <a:spcPts val="0"/>
-              </a:spcBef>
-              <a:spcAft>
-                <a:spcPts val="1400"/>
-              </a:spcAft>
-            </a:pPr>
-            <a:r>
-              <a:rPr sz="1500" b="1" i="0">
-                <a:solidFill>
-                  <a:srgbClr val="818181"/>
-                </a:solidFill>
-                <a:latin typeface="Arial"/>
-              </a:rPr>
-              <a:t>CHART B</a:t>
-            </a:r>
-          </a:p>
-          <a:p>
-            <a:pPr algn="l">
-              <a:lnSpc>
-                <a:spcPct val="120000"/>
-              </a:lnSpc>
-              <a:spcBef>
-                <a:spcPts val="0"/>
-              </a:spcBef>
-              <a:spcAft>
-                <a:spcPts val="1800"/>
-              </a:spcAft>
-            </a:pPr>
-            <a:r>
-              <a:rPr sz="2200" b="0" i="0">
-                <a:solidFill>
-                  <a:srgbClr val="1A1A1A"/>
-                </a:solidFill>
-                <a:latin typeface="Palatino"/>
-              </a:rPr>
-              <a:t>Each day's range drawn as a pale bar with its close marked on it and the closes joined into a line; the line never reaches the highs and lows that the pale bars show.</a:t>
-            </a:r>
-          </a:p>
-          <a:p>
-            <a:pPr algn="l">
-              <a:lnSpc>
-                <a:spcPct val="115000"/>
-              </a:lnSpc>
-              <a:spcBef>
-                <a:spcPts val="0"/>
-              </a:spcBef>
-              <a:spcAft>
-                <a:spcPts val="0"/>
-              </a:spcAft>
-            </a:pPr>
-            <a:r>
-              <a:rPr sz="1400" b="0" i="1">
-                <a:solidFill>
-                  <a:srgbClr val="818181"/>
-                </a:solidFill>
-                <a:latin typeface="Arial"/>
-              </a:rPr>
-              <a:t>This chart is generated by build/chartkit.py and was not drawn for this build. Rerun the build to place it.</a:t>
-            </a:r>
-          </a:p>
-        </p:txBody>
-      </p:sp>
-      <p:sp>
-        <p:nvSpPr>
-          <p:cNvPr id="10" name="TextBox 9"/>
           <p:cNvSpPr txBox="1"/>
           <p:nvPr/>
         </p:nvSpPr>
@@ -42813,8 +42528,8 @@
         </p:nvSpPr>
         <p:spPr>
           <a:xfrm>
-            <a:off x="2346807" y="1810512"/>
-            <a:ext cx="7498079" cy="3749039"/>
+            <a:off x="778611" y="1810512"/>
+            <a:ext cx="10634472" cy="3749039"/>
           </a:xfrm>
           <a:prstGeom prst="rect">
             <a:avLst/>
@@ -42837,128 +42552,33 @@
           </a:p>
         </p:txBody>
       </p:sp>
-      <p:sp>
-        <p:nvSpPr>
-          <p:cNvPr id="8" name="Rectangle 7"/>
-          <p:cNvSpPr/>
-          <p:nvPr/>
-        </p:nvSpPr>
-        <p:spPr>
-          <a:xfrm>
-            <a:off x="2346807" y="1810512"/>
-            <a:ext cx="7498079" cy="50800"/>
-          </a:xfrm>
-          <a:prstGeom prst="rect">
-            <a:avLst/>
-          </a:prstGeom>
-          <a:solidFill>
-            <a:srgbClr val="F2A900"/>
-          </a:solidFill>
-          <a:ln>
-            <a:noFill/>
-          </a:ln>
-          <a:effectLst/>
-        </p:spPr>
-        <p:txBody>
-          <a:bodyPr rtlCol="0" anchor="ctr"/>
-          <a:lstStyle/>
-          <a:p>
-            <a:pPr algn="ctr"/>
-          </a:p>
-        </p:txBody>
-      </p:sp>
+      <p:pic>
+        <p:nvPicPr>
+          <p:cNvPr id="8" name="Picture 7" descr="chart-c.png"/>
+          <p:cNvPicPr>
+            <a:picLocks noChangeAspect="1"/>
+          </p:cNvPicPr>
+          <p:nvPr/>
+        </p:nvPicPr>
+        <p:blipFill>
+          <a:blip r:embed="rId2"/>
+          <a:stretch>
+            <a:fillRect/>
+          </a:stretch>
+        </p:blipFill>
+        <p:spPr>
+          <a:xfrm>
+            <a:off x="897483" y="1929384"/>
+            <a:ext cx="10396728" cy="3511296"/>
+          </a:xfrm>
+          <a:prstGeom prst="rect">
+            <a:avLst/>
+          </a:prstGeom>
+        </p:spPr>
+      </p:pic>
       <p:sp>
         <p:nvSpPr>
           <p:cNvPr id="9" name="TextBox 8"/>
-          <p:cNvSpPr txBox="1"/>
-          <p:nvPr/>
-        </p:nvSpPr>
-        <p:spPr>
-          <a:xfrm>
-            <a:off x="2895447" y="2450591"/>
-            <a:ext cx="6400799" cy="2651759"/>
-          </a:xfrm>
-          <a:prstGeom prst="rect">
-            <a:avLst/>
-          </a:prstGeom>
-          <a:noFill/>
-        </p:spPr>
-        <p:txBody>
-          <a:bodyPr wrap="square" anchor="t" lIns="0" rIns="0" tIns="0" bIns="0">
-            <a:spAutoFit/>
-          </a:bodyPr>
-          <a:lstStyle/>
-          <a:p>
-            <a:pPr algn="l">
-              <a:lnSpc>
-                <a:spcPct val="100000"/>
-              </a:lnSpc>
-              <a:spcBef>
-                <a:spcPts val="0"/>
-              </a:spcBef>
-              <a:spcAft>
-                <a:spcPts val="1400"/>
-              </a:spcAft>
-            </a:pPr>
-            <a:r>
-              <a:rPr sz="1500" b="1" i="0">
-                <a:solidFill>
-                  <a:srgbClr val="818181"/>
-                </a:solidFill>
-                <a:latin typeface="Arial"/>
-              </a:rPr>
-              <a:t>CHART C</a:t>
-            </a:r>
-          </a:p>
-          <a:p>
-            <a:pPr algn="l">
-              <a:lnSpc>
-                <a:spcPct val="120000"/>
-              </a:lnSpc>
-              <a:spcBef>
-                <a:spcPts val="0"/>
-              </a:spcBef>
-              <a:spcAft>
-                <a:spcPts val="1800"/>
-              </a:spcAft>
-            </a:pPr>
-            <a:r>
-              <a:rPr sz="2200" b="0" i="0">
-                <a:solidFill>
-                  <a:srgbClr val="1A1A1A"/>
-                </a:solidFill>
-                <a:latin typeface="Palatino"/>
-              </a:rPr>
-              <a:t>A price path and, below it, the point and figure columns it makes with a 1 peso box and a 3 box reversal: X's while price rises, O's while it falls, a new column only after a 3 peso reversal.</a:t>
-            </a:r>
-          </a:p>
-          <a:p>
-            <a:pPr algn="l">
-              <a:lnSpc>
-                <a:spcPct val="115000"/>
-              </a:lnSpc>
-              <a:spcBef>
-                <a:spcPts val="0"/>
-              </a:spcBef>
-              <a:spcAft>
-                <a:spcPts val="0"/>
-              </a:spcAft>
-            </a:pPr>
-            <a:r>
-              <a:rPr sz="1400" b="0" i="1">
-                <a:solidFill>
-                  <a:srgbClr val="818181"/>
-                </a:solidFill>
-                <a:latin typeface="Arial"/>
-              </a:rPr>
-              <a:t>This chart is generated by build/chartkit.py and was not drawn for this build. Rerun the build to place it.</a:t>
-            </a:r>
-          </a:p>
-        </p:txBody>
-      </p:sp>
-      <p:sp>
-        <p:nvSpPr>
-          <p:cNvPr id="10" name="TextBox 9"/>
           <p:cNvSpPr txBox="1"/>
           <p:nvPr/>
         </p:nvSpPr>
@@ -45795,8 +45415,8 @@
         </p:nvSpPr>
         <p:spPr>
           <a:xfrm>
-            <a:off x="2346807" y="1810512"/>
-            <a:ext cx="7498079" cy="3749039"/>
+            <a:off x="778611" y="1810512"/>
+            <a:ext cx="10634472" cy="3749039"/>
           </a:xfrm>
           <a:prstGeom prst="rect">
             <a:avLst/>
@@ -45819,128 +45439,33 @@
           </a:p>
         </p:txBody>
       </p:sp>
-      <p:sp>
-        <p:nvSpPr>
-          <p:cNvPr id="8" name="Rectangle 7"/>
-          <p:cNvSpPr/>
-          <p:nvPr/>
-        </p:nvSpPr>
-        <p:spPr>
-          <a:xfrm>
-            <a:off x="2346807" y="1810512"/>
-            <a:ext cx="7498079" cy="50800"/>
-          </a:xfrm>
-          <a:prstGeom prst="rect">
-            <a:avLst/>
-          </a:prstGeom>
-          <a:solidFill>
-            <a:srgbClr val="F2A900"/>
-          </a:solidFill>
-          <a:ln>
-            <a:noFill/>
-          </a:ln>
-          <a:effectLst/>
-        </p:spPr>
-        <p:txBody>
-          <a:bodyPr rtlCol="0" anchor="ctr"/>
-          <a:lstStyle/>
-          <a:p>
-            <a:pPr algn="ctr"/>
-          </a:p>
-        </p:txBody>
-      </p:sp>
+      <p:pic>
+        <p:nvPicPr>
+          <p:cNvPr id="8" name="Picture 7" descr="chart-d.png"/>
+          <p:cNvPicPr>
+            <a:picLocks noChangeAspect="1"/>
+          </p:cNvPicPr>
+          <p:nvPr/>
+        </p:nvPicPr>
+        <p:blipFill>
+          <a:blip r:embed="rId2"/>
+          <a:stretch>
+            <a:fillRect/>
+          </a:stretch>
+        </p:blipFill>
+        <p:spPr>
+          <a:xfrm>
+            <a:off x="897483" y="1929384"/>
+            <a:ext cx="10396728" cy="3511296"/>
+          </a:xfrm>
+          <a:prstGeom prst="rect">
+            <a:avLst/>
+          </a:prstGeom>
+        </p:spPr>
+      </p:pic>
       <p:sp>
         <p:nvSpPr>
           <p:cNvPr id="9" name="TextBox 8"/>
-          <p:cNvSpPr txBox="1"/>
-          <p:nvPr/>
-        </p:nvSpPr>
-        <p:spPr>
-          <a:xfrm>
-            <a:off x="2895447" y="2450591"/>
-            <a:ext cx="6400799" cy="2651759"/>
-          </a:xfrm>
-          <a:prstGeom prst="rect">
-            <a:avLst/>
-          </a:prstGeom>
-          <a:noFill/>
-        </p:spPr>
-        <p:txBody>
-          <a:bodyPr wrap="square" anchor="t" lIns="0" rIns="0" tIns="0" bIns="0">
-            <a:spAutoFit/>
-          </a:bodyPr>
-          <a:lstStyle/>
-          <a:p>
-            <a:pPr algn="l">
-              <a:lnSpc>
-                <a:spcPct val="100000"/>
-              </a:lnSpc>
-              <a:spcBef>
-                <a:spcPts val="0"/>
-              </a:spcBef>
-              <a:spcAft>
-                <a:spcPts val="1400"/>
-              </a:spcAft>
-            </a:pPr>
-            <a:r>
-              <a:rPr sz="1500" b="1" i="0">
-                <a:solidFill>
-                  <a:srgbClr val="818181"/>
-                </a:solidFill>
-                <a:latin typeface="Arial"/>
-              </a:rPr>
-              <a:t>CHART D</a:t>
-            </a:r>
-          </a:p>
-          <a:p>
-            <a:pPr algn="l">
-              <a:lnSpc>
-                <a:spcPct val="120000"/>
-              </a:lnSpc>
-              <a:spcBef>
-                <a:spcPts val="0"/>
-              </a:spcBef>
-              <a:spcAft>
-                <a:spcPts val="1800"/>
-              </a:spcAft>
-            </a:pPr>
-            <a:r>
-              <a:rPr sz="2200" b="0" i="0">
-                <a:solidFill>
-                  <a:srgbClr val="1A1A1A"/>
-                </a:solidFill>
-                <a:latin typeface="Palatino"/>
-              </a:rPr>
-              <a:t>One session's price above its volume, with a mark on the time axis wherever another fixed block of shares has traded: the marks crowd together in the busy hours and spread out in the quiet ones.</a:t>
-            </a:r>
-          </a:p>
-          <a:p>
-            <a:pPr algn="l">
-              <a:lnSpc>
-                <a:spcPct val="115000"/>
-              </a:lnSpc>
-              <a:spcBef>
-                <a:spcPts val="0"/>
-              </a:spcBef>
-              <a:spcAft>
-                <a:spcPts val="0"/>
-              </a:spcAft>
-            </a:pPr>
-            <a:r>
-              <a:rPr sz="1400" b="0" i="1">
-                <a:solidFill>
-                  <a:srgbClr val="818181"/>
-                </a:solidFill>
-                <a:latin typeface="Arial"/>
-              </a:rPr>
-              <a:t>This chart is generated by build/chartkit.py and was not drawn for this build. Rerun the build to place it.</a:t>
-            </a:r>
-          </a:p>
-        </p:txBody>
-      </p:sp>
-      <p:sp>
-        <p:nvSpPr>
-          <p:cNvPr id="10" name="TextBox 9"/>
           <p:cNvSpPr txBox="1"/>
           <p:nvPr/>
         </p:nvSpPr>
@@ -52065,8 +51590,8 @@
         </p:nvSpPr>
         <p:spPr>
           <a:xfrm>
-            <a:off x="2346807" y="1810512"/>
-            <a:ext cx="7498079" cy="3749039"/>
+            <a:off x="778611" y="1810512"/>
+            <a:ext cx="10634472" cy="3749039"/>
           </a:xfrm>
           <a:prstGeom prst="rect">
             <a:avLst/>
@@ -52089,128 +51614,33 @@
           </a:p>
         </p:txBody>
       </p:sp>
-      <p:sp>
-        <p:nvSpPr>
-          <p:cNvPr id="8" name="Rectangle 7"/>
-          <p:cNvSpPr/>
-          <p:nvPr/>
-        </p:nvSpPr>
-        <p:spPr>
-          <a:xfrm>
-            <a:off x="2346807" y="1810512"/>
-            <a:ext cx="7498079" cy="50800"/>
-          </a:xfrm>
-          <a:prstGeom prst="rect">
-            <a:avLst/>
-          </a:prstGeom>
-          <a:solidFill>
-            <a:srgbClr val="F2A900"/>
-          </a:solidFill>
-          <a:ln>
-            <a:noFill/>
-          </a:ln>
-          <a:effectLst/>
-        </p:spPr>
-        <p:txBody>
-          <a:bodyPr rtlCol="0" anchor="ctr"/>
-          <a:lstStyle/>
-          <a:p>
-            <a:pPr algn="ctr"/>
-          </a:p>
-        </p:txBody>
-      </p:sp>
+      <p:pic>
+        <p:nvPicPr>
+          <p:cNvPr id="8" name="Picture 7" descr="chart-e.png"/>
+          <p:cNvPicPr>
+            <a:picLocks noChangeAspect="1"/>
+          </p:cNvPicPr>
+          <p:nvPr/>
+        </p:nvPicPr>
+        <p:blipFill>
+          <a:blip r:embed="rId2"/>
+          <a:stretch>
+            <a:fillRect/>
+          </a:stretch>
+        </p:blipFill>
+        <p:spPr>
+          <a:xfrm>
+            <a:off x="897483" y="1929384"/>
+            <a:ext cx="10396728" cy="3511296"/>
+          </a:xfrm>
+          <a:prstGeom prst="rect">
+            <a:avLst/>
+          </a:prstGeom>
+        </p:spPr>
+      </p:pic>
       <p:sp>
         <p:nvSpPr>
           <p:cNvPr id="9" name="TextBox 8"/>
-          <p:cNvSpPr txBox="1"/>
-          <p:nvPr/>
-        </p:nvSpPr>
-        <p:spPr>
-          <a:xfrm>
-            <a:off x="2895447" y="2450591"/>
-            <a:ext cx="6400799" cy="2651759"/>
-          </a:xfrm>
-          <a:prstGeom prst="rect">
-            <a:avLst/>
-          </a:prstGeom>
-          <a:noFill/>
-        </p:spPr>
-        <p:txBody>
-          <a:bodyPr wrap="square" anchor="t" lIns="0" rIns="0" tIns="0" bIns="0">
-            <a:spAutoFit/>
-          </a:bodyPr>
-          <a:lstStyle/>
-          <a:p>
-            <a:pPr algn="l">
-              <a:lnSpc>
-                <a:spcPct val="100000"/>
-              </a:lnSpc>
-              <a:spcBef>
-                <a:spcPts val="0"/>
-              </a:spcBef>
-              <a:spcAft>
-                <a:spcPts val="1400"/>
-              </a:spcAft>
-            </a:pPr>
-            <a:r>
-              <a:rPr sz="1500" b="1" i="0">
-                <a:solidFill>
-                  <a:srgbClr val="818181"/>
-                </a:solidFill>
-                <a:latin typeface="Arial"/>
-              </a:rPr>
-              <a:t>CHART E</a:t>
-            </a:r>
-          </a:p>
-          <a:p>
-            <a:pPr algn="l">
-              <a:lnSpc>
-                <a:spcPct val="120000"/>
-              </a:lnSpc>
-              <a:spcBef>
-                <a:spcPts val="0"/>
-              </a:spcBef>
-              <a:spcAft>
-                <a:spcPts val="1800"/>
-              </a:spcAft>
-            </a:pPr>
-            <a:r>
-              <a:rPr sz="2200" b="0" i="0">
-                <a:solidFill>
-                  <a:srgbClr val="1A1A1A"/>
-                </a:solidFill>
-                <a:latin typeface="Palatino"/>
-              </a:rPr>
-              <a:t>Price levels from 10 to 100 pesos on a linear, a square root and a ratio axis side by side, with the rises from 10 to 20 and from 90 to 100 marked on each.</a:t>
-            </a:r>
-          </a:p>
-          <a:p>
-            <a:pPr algn="l">
-              <a:lnSpc>
-                <a:spcPct val="115000"/>
-              </a:lnSpc>
-              <a:spcBef>
-                <a:spcPts val="0"/>
-              </a:spcBef>
-              <a:spcAft>
-                <a:spcPts val="0"/>
-              </a:spcAft>
-            </a:pPr>
-            <a:r>
-              <a:rPr sz="1400" b="0" i="1">
-                <a:solidFill>
-                  <a:srgbClr val="818181"/>
-                </a:solidFill>
-                <a:latin typeface="Arial"/>
-              </a:rPr>
-              <a:t>This chart is generated by build/chartkit.py and was not drawn for this build. Rerun the build to place it.</a:t>
-            </a:r>
-          </a:p>
-        </p:txBody>
-      </p:sp>
-      <p:sp>
-        <p:nvSpPr>
-          <p:cNvPr id="10" name="TextBox 9"/>
           <p:cNvSpPr txBox="1"/>
           <p:nvPr/>
         </p:nvSpPr>

</xml_diff>